<commit_message>
Generate daily fund reports
</commit_message>
<xml_diff>
--- a/reports/2026-09-01.pptx
+++ b/reports/2026-09-01.pptx
@@ -3386,7 +3386,7 @@
                 </a:solidFill>
                 <a:latin typeface="Microsoft YaHei"/>
               </a:rPr>
-              <a:t>-0.02%</a:t>
+              <a:t>-0.03%</a:t>
             </a:r>
           </a:p>
         </p:txBody>
@@ -3533,7 +3533,7 @@
                 </a:solidFill>
                 <a:latin typeface="Microsoft YaHei"/>
               </a:rPr>
-              <a:t>1.88%</a:t>
+              <a:t>2.27%</a:t>
             </a:r>
           </a:p>
         </p:txBody>
@@ -4235,8 +4235,162 @@
         </p:nvSpPr>
         <p:spPr>
           <a:xfrm>
-            <a:off x="2423160" y="1792224"/>
-            <a:ext cx="429038" cy="146304"/>
+            <a:off x="2055526" y="1792224"/>
+            <a:ext cx="367633" cy="146304"/>
+          </a:xfrm>
+          <a:prstGeom prst="rect">
+            <a:avLst/>
+          </a:prstGeom>
+          <a:solidFill>
+            <a:srgbClr val="BF4040"/>
+          </a:solidFill>
+          <a:ln>
+            <a:noFill/>
+          </a:ln>
+        </p:spPr>
+        <p:style>
+          <a:lnRef idx="1">
+            <a:schemeClr val="accent1"/>
+          </a:lnRef>
+          <a:fillRef idx="3">
+            <a:schemeClr val="accent1"/>
+          </a:fillRef>
+          <a:effectRef idx="2">
+            <a:schemeClr val="accent1"/>
+          </a:effectRef>
+          <a:fontRef idx="minor">
+            <a:schemeClr val="lt1"/>
+          </a:fontRef>
+        </p:style>
+        <p:txBody>
+          <a:bodyPr rtlCol="0" anchor="ctr"/>
+          <a:lstStyle/>
+          <a:p>
+            <a:pPr algn="ctr"/>
+          </a:p>
+        </p:txBody>
+      </p:sp>
+      <p:sp>
+        <p:nvSpPr>
+          <p:cNvPr id="9" name="TextBox 8"/>
+          <p:cNvSpPr txBox="1"/>
+          <p:nvPr/>
+        </p:nvSpPr>
+        <p:spPr>
+          <a:xfrm>
+            <a:off x="2468879" y="1746504"/>
+            <a:ext cx="502920" cy="201168"/>
+          </a:xfrm>
+          <a:prstGeom prst="rect">
+            <a:avLst/>
+          </a:prstGeom>
+          <a:noFill/>
+        </p:spPr>
+        <p:txBody>
+          <a:bodyPr wrap="none" lIns="18288" rIns="18288" tIns="18288" bIns="18288">
+            <a:spAutoFit/>
+          </a:bodyPr>
+          <a:lstStyle/>
+          <a:p>
+            <a:r>
+              <a:rPr sz="800" b="0">
+                <a:solidFill>
+                  <a:srgbClr val="1A2026"/>
+                </a:solidFill>
+                <a:latin typeface="Microsoft YaHei"/>
+              </a:rPr>
+              <a:t>-0.28%</a:t>
+            </a:r>
+          </a:p>
+        </p:txBody>
+      </p:sp>
+      <p:sp>
+        <p:nvSpPr>
+          <p:cNvPr id="10" name="TextBox 9"/>
+          <p:cNvSpPr txBox="1"/>
+          <p:nvPr/>
+        </p:nvSpPr>
+        <p:spPr>
+          <a:xfrm>
+            <a:off x="640080" y="2121408"/>
+            <a:ext cx="1078992" cy="201168"/>
+          </a:xfrm>
+          <a:prstGeom prst="rect">
+            <a:avLst/>
+          </a:prstGeom>
+          <a:noFill/>
+        </p:spPr>
+        <p:txBody>
+          <a:bodyPr wrap="none" lIns="18288" rIns="18288" tIns="18288" bIns="18288">
+            <a:spAutoFit/>
+          </a:bodyPr>
+          <a:lstStyle/>
+          <a:p>
+            <a:r>
+              <a:rPr sz="800" b="0">
+                <a:solidFill>
+                  <a:srgbClr val="65707D"/>
+                </a:solidFill>
+                <a:latin typeface="Microsoft YaHei"/>
+              </a:rPr>
+              <a:t>富国红利精选QD</a:t>
+            </a:r>
+          </a:p>
+        </p:txBody>
+      </p:sp>
+      <p:sp>
+        <p:nvSpPr>
+          <p:cNvPr id="11" name="Rectangle 10"/>
+          <p:cNvSpPr/>
+          <p:nvPr/>
+        </p:nvSpPr>
+        <p:spPr>
+          <a:xfrm>
+            <a:off x="2423160" y="2194560"/>
+            <a:ext cx="9144" cy="118872"/>
+          </a:xfrm>
+          <a:prstGeom prst="rect">
+            <a:avLst/>
+          </a:prstGeom>
+          <a:solidFill>
+            <a:srgbClr val="DAD5C9"/>
+          </a:solidFill>
+          <a:ln>
+            <a:noFill/>
+          </a:ln>
+        </p:spPr>
+        <p:style>
+          <a:lnRef idx="1">
+            <a:schemeClr val="accent1"/>
+          </a:lnRef>
+          <a:fillRef idx="3">
+            <a:schemeClr val="accent1"/>
+          </a:fillRef>
+          <a:effectRef idx="2">
+            <a:schemeClr val="accent1"/>
+          </a:effectRef>
+          <a:fontRef idx="minor">
+            <a:schemeClr val="lt1"/>
+          </a:fontRef>
+        </p:style>
+        <p:txBody>
+          <a:bodyPr rtlCol="0" anchor="ctr"/>
+          <a:lstStyle/>
+          <a:p>
+            <a:pPr algn="ctr"/>
+          </a:p>
+        </p:txBody>
+      </p:sp>
+      <p:sp>
+        <p:nvSpPr>
+          <p:cNvPr id="12" name="Rectangle 11"/>
+          <p:cNvSpPr/>
+          <p:nvPr/>
+        </p:nvSpPr>
+        <p:spPr>
+          <a:xfrm>
+            <a:off x="2423160" y="2176272"/>
+            <a:ext cx="208111" cy="146304"/>
           </a:xfrm>
           <a:prstGeom prst="rect">
             <a:avLst/>
@@ -4272,13 +4426,13 @@
       </p:sp>
       <p:sp>
         <p:nvSpPr>
-          <p:cNvPr id="9" name="TextBox 8"/>
-          <p:cNvSpPr txBox="1"/>
-          <p:nvPr/>
-        </p:nvSpPr>
-        <p:spPr>
-          <a:xfrm>
-            <a:off x="2897918" y="1746504"/>
+          <p:cNvPr id="13" name="TextBox 12"/>
+          <p:cNvSpPr txBox="1"/>
+          <p:nvPr/>
+        </p:nvSpPr>
+        <p:spPr>
+          <a:xfrm>
+            <a:off x="2676991" y="2130552"/>
             <a:ext cx="502920" cy="201168"/>
           </a:xfrm>
           <a:prstGeom prst="rect">
@@ -4299,20 +4453,20 @@
                 </a:solidFill>
                 <a:latin typeface="Microsoft YaHei"/>
               </a:rPr>
-              <a:t>0.32%</a:t>
-            </a:r>
-          </a:p>
-        </p:txBody>
-      </p:sp>
-      <p:sp>
-        <p:nvSpPr>
-          <p:cNvPr id="10" name="TextBox 9"/>
-          <p:cNvSpPr txBox="1"/>
-          <p:nvPr/>
-        </p:nvSpPr>
-        <p:spPr>
-          <a:xfrm>
-            <a:off x="640080" y="2121408"/>
+              <a:t>0.16%</a:t>
+            </a:r>
+          </a:p>
+        </p:txBody>
+      </p:sp>
+      <p:sp>
+        <p:nvSpPr>
+          <p:cNvPr id="14" name="TextBox 13"/>
+          <p:cNvSpPr txBox="1"/>
+          <p:nvPr/>
+        </p:nvSpPr>
+        <p:spPr>
+          <a:xfrm>
+            <a:off x="640080" y="2505456"/>
             <a:ext cx="1078992" cy="201168"/>
           </a:xfrm>
           <a:prstGeom prst="rect">
@@ -4333,20 +4487,20 @@
                 </a:solidFill>
                 <a:latin typeface="Microsoft YaHei"/>
               </a:rPr>
-              <a:t>富国红利精选QD</a:t>
-            </a:r>
-          </a:p>
-        </p:txBody>
-      </p:sp>
-      <p:sp>
-        <p:nvSpPr>
-          <p:cNvPr id="11" name="Rectangle 10"/>
+              <a:t>纳斯达克100指</a:t>
+            </a:r>
+          </a:p>
+        </p:txBody>
+      </p:sp>
+      <p:sp>
+        <p:nvSpPr>
+          <p:cNvPr id="15" name="Rectangle 14"/>
           <p:cNvSpPr/>
           <p:nvPr/>
         </p:nvSpPr>
         <p:spPr>
           <a:xfrm>
-            <a:off x="2423160" y="2194560"/>
+            <a:off x="2423160" y="2578608"/>
             <a:ext cx="9144" cy="118872"/>
           </a:xfrm>
           <a:prstGeom prst="rect">
@@ -4383,14 +4537,14 @@
       </p:sp>
       <p:sp>
         <p:nvSpPr>
-          <p:cNvPr id="12" name="Rectangle 11"/>
+          <p:cNvPr id="16" name="Rectangle 15"/>
           <p:cNvSpPr/>
           <p:nvPr/>
         </p:nvSpPr>
         <p:spPr>
           <a:xfrm>
-            <a:off x="2423160" y="2176272"/>
-            <a:ext cx="424515" cy="146304"/>
+            <a:off x="2423160" y="2560320"/>
+            <a:ext cx="72069" cy="146304"/>
           </a:xfrm>
           <a:prstGeom prst="rect">
             <a:avLst/>
@@ -4426,13 +4580,13 @@
       </p:sp>
       <p:sp>
         <p:nvSpPr>
-          <p:cNvPr id="13" name="TextBox 12"/>
-          <p:cNvSpPr txBox="1"/>
-          <p:nvPr/>
-        </p:nvSpPr>
-        <p:spPr>
-          <a:xfrm>
-            <a:off x="2893395" y="2130552"/>
+          <p:cNvPr id="17" name="TextBox 16"/>
+          <p:cNvSpPr txBox="1"/>
+          <p:nvPr/>
+        </p:nvSpPr>
+        <p:spPr>
+          <a:xfrm>
+            <a:off x="2540949" y="2514600"/>
             <a:ext cx="502920" cy="201168"/>
           </a:xfrm>
           <a:prstGeom prst="rect">
@@ -4453,20 +4607,20 @@
                 </a:solidFill>
                 <a:latin typeface="Microsoft YaHei"/>
               </a:rPr>
-              <a:t>0.32%</a:t>
-            </a:r>
-          </a:p>
-        </p:txBody>
-      </p:sp>
-      <p:sp>
-        <p:nvSpPr>
-          <p:cNvPr id="14" name="TextBox 13"/>
-          <p:cNvSpPr txBox="1"/>
-          <p:nvPr/>
-        </p:nvSpPr>
-        <p:spPr>
-          <a:xfrm>
-            <a:off x="640080" y="2505456"/>
+              <a:t>0.05%</a:t>
+            </a:r>
+          </a:p>
+        </p:txBody>
+      </p:sp>
+      <p:sp>
+        <p:nvSpPr>
+          <p:cNvPr id="18" name="TextBox 17"/>
+          <p:cNvSpPr txBox="1"/>
+          <p:nvPr/>
+        </p:nvSpPr>
+        <p:spPr>
+          <a:xfrm>
+            <a:off x="640080" y="2889503"/>
             <a:ext cx="1078992" cy="201168"/>
           </a:xfrm>
           <a:prstGeom prst="rect">
@@ -4487,20 +4641,20 @@
                 </a:solidFill>
                 <a:latin typeface="Microsoft YaHei"/>
               </a:rPr>
-              <a:t>纳斯达克100指</a:t>
-            </a:r>
-          </a:p>
-        </p:txBody>
-      </p:sp>
-      <p:sp>
-        <p:nvSpPr>
-          <p:cNvPr id="15" name="Rectangle 14"/>
+              <a:t>兴全安泰积极养老</a:t>
+            </a:r>
+          </a:p>
+        </p:txBody>
+      </p:sp>
+      <p:sp>
+        <p:nvSpPr>
+          <p:cNvPr id="19" name="Rectangle 18"/>
           <p:cNvSpPr/>
           <p:nvPr/>
         </p:nvSpPr>
         <p:spPr>
           <a:xfrm>
-            <a:off x="2423160" y="2578608"/>
+            <a:off x="2423160" y="2962656"/>
             <a:ext cx="9144" cy="118872"/>
           </a:xfrm>
           <a:prstGeom prst="rect">
@@ -4537,14 +4691,14 @@
       </p:sp>
       <p:sp>
         <p:nvSpPr>
-          <p:cNvPr id="16" name="Rectangle 15"/>
+          <p:cNvPr id="20" name="Rectangle 19"/>
           <p:cNvSpPr/>
           <p:nvPr/>
         </p:nvSpPr>
         <p:spPr>
           <a:xfrm>
-            <a:off x="1557465" y="2560320"/>
-            <a:ext cx="865694" cy="146304"/>
+            <a:off x="2053863" y="2944368"/>
+            <a:ext cx="369296" cy="146304"/>
           </a:xfrm>
           <a:prstGeom prst="rect">
             <a:avLst/>
@@ -4580,13 +4734,13 @@
       </p:sp>
       <p:sp>
         <p:nvSpPr>
-          <p:cNvPr id="17" name="TextBox 16"/>
-          <p:cNvSpPr txBox="1"/>
-          <p:nvPr/>
-        </p:nvSpPr>
-        <p:spPr>
-          <a:xfrm>
-            <a:off x="2468879" y="2514600"/>
+          <p:cNvPr id="21" name="TextBox 20"/>
+          <p:cNvSpPr txBox="1"/>
+          <p:nvPr/>
+        </p:nvSpPr>
+        <p:spPr>
+          <a:xfrm>
+            <a:off x="2468879" y="2898648"/>
             <a:ext cx="502920" cy="201168"/>
           </a:xfrm>
           <a:prstGeom prst="rect">
@@ -4607,20 +4761,20 @@
                 </a:solidFill>
                 <a:latin typeface="Microsoft YaHei"/>
               </a:rPr>
-              <a:t>-0.65%</a:t>
-            </a:r>
-          </a:p>
-        </p:txBody>
-      </p:sp>
-      <p:sp>
-        <p:nvSpPr>
-          <p:cNvPr id="18" name="TextBox 17"/>
-          <p:cNvSpPr txBox="1"/>
-          <p:nvPr/>
-        </p:nvSpPr>
-        <p:spPr>
-          <a:xfrm>
-            <a:off x="640080" y="2889503"/>
+              <a:t>-0.28%</a:t>
+            </a:r>
+          </a:p>
+        </p:txBody>
+      </p:sp>
+      <p:sp>
+        <p:nvSpPr>
+          <p:cNvPr id="22" name="TextBox 21"/>
+          <p:cNvSpPr txBox="1"/>
+          <p:nvPr/>
+        </p:nvSpPr>
+        <p:spPr>
+          <a:xfrm>
+            <a:off x="640080" y="3273551"/>
             <a:ext cx="1078992" cy="201168"/>
           </a:xfrm>
           <a:prstGeom prst="rect">
@@ -4641,20 +4795,20 @@
                 </a:solidFill>
                 <a:latin typeface="Microsoft YaHei"/>
               </a:rPr>
-              <a:t>兴全安泰积极养老</a:t>
-            </a:r>
-          </a:p>
-        </p:txBody>
-      </p:sp>
-      <p:sp>
-        <p:nvSpPr>
-          <p:cNvPr id="19" name="Rectangle 18"/>
+              <a:t>易方达全球优质企</a:t>
+            </a:r>
+          </a:p>
+        </p:txBody>
+      </p:sp>
+      <p:sp>
+        <p:nvSpPr>
+          <p:cNvPr id="23" name="Rectangle 22"/>
           <p:cNvSpPr/>
           <p:nvPr/>
         </p:nvSpPr>
         <p:spPr>
           <a:xfrm>
-            <a:off x="2423160" y="2962656"/>
+            <a:off x="2423160" y="3346703"/>
             <a:ext cx="9144" cy="118872"/>
           </a:xfrm>
           <a:prstGeom prst="rect">
@@ -4691,14 +4845,14 @@
       </p:sp>
       <p:sp>
         <p:nvSpPr>
-          <p:cNvPr id="20" name="Rectangle 19"/>
+          <p:cNvPr id="24" name="Rectangle 23"/>
           <p:cNvSpPr/>
           <p:nvPr/>
         </p:nvSpPr>
         <p:spPr>
           <a:xfrm>
-            <a:off x="2423160" y="2944368"/>
-            <a:ext cx="860202" cy="146304"/>
+            <a:off x="2423160" y="3328415"/>
+            <a:ext cx="256164" cy="146304"/>
           </a:xfrm>
           <a:prstGeom prst="rect">
             <a:avLst/>
@@ -4734,13 +4888,13 @@
       </p:sp>
       <p:sp>
         <p:nvSpPr>
-          <p:cNvPr id="21" name="TextBox 20"/>
-          <p:cNvSpPr txBox="1"/>
-          <p:nvPr/>
-        </p:nvSpPr>
-        <p:spPr>
-          <a:xfrm>
-            <a:off x="3329082" y="2898648"/>
+          <p:cNvPr id="25" name="TextBox 24"/>
+          <p:cNvSpPr txBox="1"/>
+          <p:nvPr/>
+        </p:nvSpPr>
+        <p:spPr>
+          <a:xfrm>
+            <a:off x="2725044" y="3282696"/>
             <a:ext cx="502920" cy="201168"/>
           </a:xfrm>
           <a:prstGeom prst="rect">
@@ -4761,20 +4915,54 @@
                 </a:solidFill>
                 <a:latin typeface="Microsoft YaHei"/>
               </a:rPr>
-              <a:t>0.65%</a:t>
-            </a:r>
-          </a:p>
-        </p:txBody>
-      </p:sp>
-      <p:sp>
-        <p:nvSpPr>
-          <p:cNvPr id="22" name="TextBox 21"/>
-          <p:cNvSpPr txBox="1"/>
-          <p:nvPr/>
-        </p:nvSpPr>
-        <p:spPr>
-          <a:xfrm>
-            <a:off x="640080" y="3273551"/>
+              <a:t>0.19%</a:t>
+            </a:r>
+          </a:p>
+        </p:txBody>
+      </p:sp>
+      <p:sp>
+        <p:nvSpPr>
+          <p:cNvPr id="26" name="TextBox 25"/>
+          <p:cNvSpPr txBox="1"/>
+          <p:nvPr/>
+        </p:nvSpPr>
+        <p:spPr>
+          <a:xfrm>
+            <a:off x="4251960" y="1371600"/>
+            <a:ext cx="3383280" cy="219456"/>
+          </a:xfrm>
+          <a:prstGeom prst="rect">
+            <a:avLst/>
+          </a:prstGeom>
+          <a:noFill/>
+        </p:spPr>
+        <p:txBody>
+          <a:bodyPr wrap="none" lIns="18288" rIns="18288" tIns="18288" bIns="18288">
+            <a:spAutoFit/>
+          </a:bodyPr>
+          <a:lstStyle/>
+          <a:p>
+            <a:r>
+              <a:rPr sz="1100" b="1">
+                <a:solidFill>
+                  <a:srgbClr val="1A2026"/>
+                </a:solidFill>
+                <a:latin typeface="Microsoft YaHei"/>
+              </a:rPr>
+              <a:t>近1周收益</a:t>
+            </a:r>
+          </a:p>
+        </p:txBody>
+      </p:sp>
+      <p:sp>
+        <p:nvSpPr>
+          <p:cNvPr id="27" name="TextBox 26"/>
+          <p:cNvSpPr txBox="1"/>
+          <p:nvPr/>
+        </p:nvSpPr>
+        <p:spPr>
+          <a:xfrm>
+            <a:off x="4251960" y="1737360"/>
             <a:ext cx="1078992" cy="201168"/>
           </a:xfrm>
           <a:prstGeom prst="rect">
@@ -4795,20 +4983,20 @@
                 </a:solidFill>
                 <a:latin typeface="Microsoft YaHei"/>
               </a:rPr>
-              <a:t>易方达全球优质企</a:t>
-            </a:r>
-          </a:p>
-        </p:txBody>
-      </p:sp>
-      <p:sp>
-        <p:nvSpPr>
-          <p:cNvPr id="23" name="Rectangle 22"/>
+              <a:t>华夏沪深300E</a:t>
+            </a:r>
+          </a:p>
+        </p:txBody>
+      </p:sp>
+      <p:sp>
+        <p:nvSpPr>
+          <p:cNvPr id="28" name="Rectangle 27"/>
           <p:cNvSpPr/>
           <p:nvPr/>
         </p:nvSpPr>
         <p:spPr>
           <a:xfrm>
-            <a:off x="2423160" y="3346703"/>
+            <a:off x="6035040" y="1810512"/>
             <a:ext cx="9144" cy="118872"/>
           </a:xfrm>
           <a:prstGeom prst="rect">
@@ -4845,14 +5033,476 @@
       </p:sp>
       <p:sp>
         <p:nvSpPr>
-          <p:cNvPr id="24" name="Rectangle 23"/>
+          <p:cNvPr id="29" name="Rectangle 28"/>
           <p:cNvSpPr/>
           <p:nvPr/>
         </p:nvSpPr>
         <p:spPr>
           <a:xfrm>
-            <a:off x="1432237" y="3328415"/>
-            <a:ext cx="990922" cy="146304"/>
+            <a:off x="6035040" y="1792224"/>
+            <a:ext cx="873917" cy="146304"/>
+          </a:xfrm>
+          <a:prstGeom prst="rect">
+            <a:avLst/>
+          </a:prstGeom>
+          <a:solidFill>
+            <a:srgbClr val="198974"/>
+          </a:solidFill>
+          <a:ln>
+            <a:noFill/>
+          </a:ln>
+        </p:spPr>
+        <p:style>
+          <a:lnRef idx="1">
+            <a:schemeClr val="accent1"/>
+          </a:lnRef>
+          <a:fillRef idx="3">
+            <a:schemeClr val="accent1"/>
+          </a:fillRef>
+          <a:effectRef idx="2">
+            <a:schemeClr val="accent1"/>
+          </a:effectRef>
+          <a:fontRef idx="minor">
+            <a:schemeClr val="lt1"/>
+          </a:fontRef>
+        </p:style>
+        <p:txBody>
+          <a:bodyPr rtlCol="0" anchor="ctr"/>
+          <a:lstStyle/>
+          <a:p>
+            <a:pPr algn="ctr"/>
+          </a:p>
+        </p:txBody>
+      </p:sp>
+      <p:sp>
+        <p:nvSpPr>
+          <p:cNvPr id="30" name="TextBox 29"/>
+          <p:cNvSpPr txBox="1"/>
+          <p:nvPr/>
+        </p:nvSpPr>
+        <p:spPr>
+          <a:xfrm>
+            <a:off x="6954677" y="1746504"/>
+            <a:ext cx="502920" cy="201168"/>
+          </a:xfrm>
+          <a:prstGeom prst="rect">
+            <a:avLst/>
+          </a:prstGeom>
+          <a:noFill/>
+        </p:spPr>
+        <p:txBody>
+          <a:bodyPr wrap="none" lIns="18288" rIns="18288" tIns="18288" bIns="18288">
+            <a:spAutoFit/>
+          </a:bodyPr>
+          <a:lstStyle/>
+          <a:p>
+            <a:r>
+              <a:rPr sz="800" b="0">
+                <a:solidFill>
+                  <a:srgbClr val="1A2026"/>
+                </a:solidFill>
+                <a:latin typeface="Microsoft YaHei"/>
+              </a:rPr>
+              <a:t>1.30%</a:t>
+            </a:r>
+          </a:p>
+        </p:txBody>
+      </p:sp>
+      <p:sp>
+        <p:nvSpPr>
+          <p:cNvPr id="31" name="TextBox 30"/>
+          <p:cNvSpPr txBox="1"/>
+          <p:nvPr/>
+        </p:nvSpPr>
+        <p:spPr>
+          <a:xfrm>
+            <a:off x="4251960" y="2121408"/>
+            <a:ext cx="1078992" cy="201168"/>
+          </a:xfrm>
+          <a:prstGeom prst="rect">
+            <a:avLst/>
+          </a:prstGeom>
+          <a:noFill/>
+        </p:spPr>
+        <p:txBody>
+          <a:bodyPr wrap="none" lIns="18288" rIns="18288" tIns="18288" bIns="18288">
+            <a:spAutoFit/>
+          </a:bodyPr>
+          <a:lstStyle/>
+          <a:p>
+            <a:r>
+              <a:rPr sz="800" b="0">
+                <a:solidFill>
+                  <a:srgbClr val="65707D"/>
+                </a:solidFill>
+                <a:latin typeface="Microsoft YaHei"/>
+              </a:rPr>
+              <a:t>富国红利精选QD</a:t>
+            </a:r>
+          </a:p>
+        </p:txBody>
+      </p:sp>
+      <p:sp>
+        <p:nvSpPr>
+          <p:cNvPr id="32" name="Rectangle 31"/>
+          <p:cNvSpPr/>
+          <p:nvPr/>
+        </p:nvSpPr>
+        <p:spPr>
+          <a:xfrm>
+            <a:off x="6035040" y="2194560"/>
+            <a:ext cx="9144" cy="118872"/>
+          </a:xfrm>
+          <a:prstGeom prst="rect">
+            <a:avLst/>
+          </a:prstGeom>
+          <a:solidFill>
+            <a:srgbClr val="DAD5C9"/>
+          </a:solidFill>
+          <a:ln>
+            <a:noFill/>
+          </a:ln>
+        </p:spPr>
+        <p:style>
+          <a:lnRef idx="1">
+            <a:schemeClr val="accent1"/>
+          </a:lnRef>
+          <a:fillRef idx="3">
+            <a:schemeClr val="accent1"/>
+          </a:fillRef>
+          <a:effectRef idx="2">
+            <a:schemeClr val="accent1"/>
+          </a:effectRef>
+          <a:fontRef idx="minor">
+            <a:schemeClr val="lt1"/>
+          </a:fontRef>
+        </p:style>
+        <p:txBody>
+          <a:bodyPr rtlCol="0" anchor="ctr"/>
+          <a:lstStyle/>
+          <a:p>
+            <a:pPr algn="ctr"/>
+          </a:p>
+        </p:txBody>
+      </p:sp>
+      <p:sp>
+        <p:nvSpPr>
+          <p:cNvPr id="33" name="Rectangle 32"/>
+          <p:cNvSpPr/>
+          <p:nvPr/>
+        </p:nvSpPr>
+        <p:spPr>
+          <a:xfrm>
+            <a:off x="6035040" y="2176272"/>
+            <a:ext cx="1325880" cy="146304"/>
+          </a:xfrm>
+          <a:prstGeom prst="rect">
+            <a:avLst/>
+          </a:prstGeom>
+          <a:solidFill>
+            <a:srgbClr val="198974"/>
+          </a:solidFill>
+          <a:ln>
+            <a:noFill/>
+          </a:ln>
+        </p:spPr>
+        <p:style>
+          <a:lnRef idx="1">
+            <a:schemeClr val="accent1"/>
+          </a:lnRef>
+          <a:fillRef idx="3">
+            <a:schemeClr val="accent1"/>
+          </a:fillRef>
+          <a:effectRef idx="2">
+            <a:schemeClr val="accent1"/>
+          </a:effectRef>
+          <a:fontRef idx="minor">
+            <a:schemeClr val="lt1"/>
+          </a:fontRef>
+        </p:style>
+        <p:txBody>
+          <a:bodyPr rtlCol="0" anchor="ctr"/>
+          <a:lstStyle/>
+          <a:p>
+            <a:pPr algn="ctr"/>
+          </a:p>
+        </p:txBody>
+      </p:sp>
+      <p:sp>
+        <p:nvSpPr>
+          <p:cNvPr id="34" name="TextBox 33"/>
+          <p:cNvSpPr txBox="1"/>
+          <p:nvPr/>
+        </p:nvSpPr>
+        <p:spPr>
+          <a:xfrm>
+            <a:off x="7406640" y="2130552"/>
+            <a:ext cx="502920" cy="201168"/>
+          </a:xfrm>
+          <a:prstGeom prst="rect">
+            <a:avLst/>
+          </a:prstGeom>
+          <a:noFill/>
+        </p:spPr>
+        <p:txBody>
+          <a:bodyPr wrap="none" lIns="18288" rIns="18288" tIns="18288" bIns="18288">
+            <a:spAutoFit/>
+          </a:bodyPr>
+          <a:lstStyle/>
+          <a:p>
+            <a:r>
+              <a:rPr sz="800" b="0">
+                <a:solidFill>
+                  <a:srgbClr val="1A2026"/>
+                </a:solidFill>
+                <a:latin typeface="Microsoft YaHei"/>
+              </a:rPr>
+              <a:t>1.97%</a:t>
+            </a:r>
+          </a:p>
+        </p:txBody>
+      </p:sp>
+      <p:sp>
+        <p:nvSpPr>
+          <p:cNvPr id="35" name="TextBox 34"/>
+          <p:cNvSpPr txBox="1"/>
+          <p:nvPr/>
+        </p:nvSpPr>
+        <p:spPr>
+          <a:xfrm>
+            <a:off x="4251960" y="2505456"/>
+            <a:ext cx="1078992" cy="201168"/>
+          </a:xfrm>
+          <a:prstGeom prst="rect">
+            <a:avLst/>
+          </a:prstGeom>
+          <a:noFill/>
+        </p:spPr>
+        <p:txBody>
+          <a:bodyPr wrap="none" lIns="18288" rIns="18288" tIns="18288" bIns="18288">
+            <a:spAutoFit/>
+          </a:bodyPr>
+          <a:lstStyle/>
+          <a:p>
+            <a:r>
+              <a:rPr sz="800" b="0">
+                <a:solidFill>
+                  <a:srgbClr val="65707D"/>
+                </a:solidFill>
+                <a:latin typeface="Microsoft YaHei"/>
+              </a:rPr>
+              <a:t>纳斯达克100指</a:t>
+            </a:r>
+          </a:p>
+        </p:txBody>
+      </p:sp>
+      <p:sp>
+        <p:nvSpPr>
+          <p:cNvPr id="36" name="Rectangle 35"/>
+          <p:cNvSpPr/>
+          <p:nvPr/>
+        </p:nvSpPr>
+        <p:spPr>
+          <a:xfrm>
+            <a:off x="6035040" y="2578608"/>
+            <a:ext cx="9144" cy="118872"/>
+          </a:xfrm>
+          <a:prstGeom prst="rect">
+            <a:avLst/>
+          </a:prstGeom>
+          <a:solidFill>
+            <a:srgbClr val="DAD5C9"/>
+          </a:solidFill>
+          <a:ln>
+            <a:noFill/>
+          </a:ln>
+        </p:spPr>
+        <p:style>
+          <a:lnRef idx="1">
+            <a:schemeClr val="accent1"/>
+          </a:lnRef>
+          <a:fillRef idx="3">
+            <a:schemeClr val="accent1"/>
+          </a:fillRef>
+          <a:effectRef idx="2">
+            <a:schemeClr val="accent1"/>
+          </a:effectRef>
+          <a:fontRef idx="minor">
+            <a:schemeClr val="lt1"/>
+          </a:fontRef>
+        </p:style>
+        <p:txBody>
+          <a:bodyPr rtlCol="0" anchor="ctr"/>
+          <a:lstStyle/>
+          <a:p>
+            <a:pPr algn="ctr"/>
+          </a:p>
+        </p:txBody>
+      </p:sp>
+      <p:sp>
+        <p:nvSpPr>
+          <p:cNvPr id="37" name="Rectangle 36"/>
+          <p:cNvSpPr/>
+          <p:nvPr/>
+        </p:nvSpPr>
+        <p:spPr>
+          <a:xfrm>
+            <a:off x="6035040" y="2560320"/>
+            <a:ext cx="888705" cy="146304"/>
+          </a:xfrm>
+          <a:prstGeom prst="rect">
+            <a:avLst/>
+          </a:prstGeom>
+          <a:solidFill>
+            <a:srgbClr val="198974"/>
+          </a:solidFill>
+          <a:ln>
+            <a:noFill/>
+          </a:ln>
+        </p:spPr>
+        <p:style>
+          <a:lnRef idx="1">
+            <a:schemeClr val="accent1"/>
+          </a:lnRef>
+          <a:fillRef idx="3">
+            <a:schemeClr val="accent1"/>
+          </a:fillRef>
+          <a:effectRef idx="2">
+            <a:schemeClr val="accent1"/>
+          </a:effectRef>
+          <a:fontRef idx="minor">
+            <a:schemeClr val="lt1"/>
+          </a:fontRef>
+        </p:style>
+        <p:txBody>
+          <a:bodyPr rtlCol="0" anchor="ctr"/>
+          <a:lstStyle/>
+          <a:p>
+            <a:pPr algn="ctr"/>
+          </a:p>
+        </p:txBody>
+      </p:sp>
+      <p:sp>
+        <p:nvSpPr>
+          <p:cNvPr id="38" name="TextBox 37"/>
+          <p:cNvSpPr txBox="1"/>
+          <p:nvPr/>
+        </p:nvSpPr>
+        <p:spPr>
+          <a:xfrm>
+            <a:off x="6969465" y="2514600"/>
+            <a:ext cx="502920" cy="201168"/>
+          </a:xfrm>
+          <a:prstGeom prst="rect">
+            <a:avLst/>
+          </a:prstGeom>
+          <a:noFill/>
+        </p:spPr>
+        <p:txBody>
+          <a:bodyPr wrap="none" lIns="18288" rIns="18288" tIns="18288" bIns="18288">
+            <a:spAutoFit/>
+          </a:bodyPr>
+          <a:lstStyle/>
+          <a:p>
+            <a:r>
+              <a:rPr sz="800" b="0">
+                <a:solidFill>
+                  <a:srgbClr val="1A2026"/>
+                </a:solidFill>
+                <a:latin typeface="Microsoft YaHei"/>
+              </a:rPr>
+              <a:t>1.32%</a:t>
+            </a:r>
+          </a:p>
+        </p:txBody>
+      </p:sp>
+      <p:sp>
+        <p:nvSpPr>
+          <p:cNvPr id="39" name="TextBox 38"/>
+          <p:cNvSpPr txBox="1"/>
+          <p:nvPr/>
+        </p:nvSpPr>
+        <p:spPr>
+          <a:xfrm>
+            <a:off x="4251960" y="2889503"/>
+            <a:ext cx="1078992" cy="201168"/>
+          </a:xfrm>
+          <a:prstGeom prst="rect">
+            <a:avLst/>
+          </a:prstGeom>
+          <a:noFill/>
+        </p:spPr>
+        <p:txBody>
+          <a:bodyPr wrap="none" lIns="18288" rIns="18288" tIns="18288" bIns="18288">
+            <a:spAutoFit/>
+          </a:bodyPr>
+          <a:lstStyle/>
+          <a:p>
+            <a:r>
+              <a:rPr sz="800" b="0">
+                <a:solidFill>
+                  <a:srgbClr val="65707D"/>
+                </a:solidFill>
+                <a:latin typeface="Microsoft YaHei"/>
+              </a:rPr>
+              <a:t>兴全安泰积极养老</a:t>
+            </a:r>
+          </a:p>
+        </p:txBody>
+      </p:sp>
+      <p:sp>
+        <p:nvSpPr>
+          <p:cNvPr id="40" name="Rectangle 39"/>
+          <p:cNvSpPr/>
+          <p:nvPr/>
+        </p:nvSpPr>
+        <p:spPr>
+          <a:xfrm>
+            <a:off x="6035040" y="2962656"/>
+            <a:ext cx="9144" cy="118872"/>
+          </a:xfrm>
+          <a:prstGeom prst="rect">
+            <a:avLst/>
+          </a:prstGeom>
+          <a:solidFill>
+            <a:srgbClr val="DAD5C9"/>
+          </a:solidFill>
+          <a:ln>
+            <a:noFill/>
+          </a:ln>
+        </p:spPr>
+        <p:style>
+          <a:lnRef idx="1">
+            <a:schemeClr val="accent1"/>
+          </a:lnRef>
+          <a:fillRef idx="3">
+            <a:schemeClr val="accent1"/>
+          </a:fillRef>
+          <a:effectRef idx="2">
+            <a:schemeClr val="accent1"/>
+          </a:effectRef>
+          <a:fontRef idx="minor">
+            <a:schemeClr val="lt1"/>
+          </a:fontRef>
+        </p:style>
+        <p:txBody>
+          <a:bodyPr rtlCol="0" anchor="ctr"/>
+          <a:lstStyle/>
+          <a:p>
+            <a:pPr algn="ctr"/>
+          </a:p>
+        </p:txBody>
+      </p:sp>
+      <p:sp>
+        <p:nvSpPr>
+          <p:cNvPr id="41" name="Rectangle 40"/>
+          <p:cNvSpPr/>
+          <p:nvPr/>
+        </p:nvSpPr>
+        <p:spPr>
+          <a:xfrm>
+            <a:off x="5911791" y="2944368"/>
+            <a:ext cx="123248" cy="146304"/>
           </a:xfrm>
           <a:prstGeom prst="rect">
             <a:avLst/>
@@ -4888,13 +5538,13 @@
       </p:sp>
       <p:sp>
         <p:nvSpPr>
-          <p:cNvPr id="25" name="TextBox 24"/>
-          <p:cNvSpPr txBox="1"/>
-          <p:nvPr/>
-        </p:nvSpPr>
-        <p:spPr>
-          <a:xfrm>
-            <a:off x="2468879" y="3282696"/>
+          <p:cNvPr id="42" name="TextBox 41"/>
+          <p:cNvSpPr txBox="1"/>
+          <p:nvPr/>
+        </p:nvSpPr>
+        <p:spPr>
+          <a:xfrm>
+            <a:off x="6080760" y="2898648"/>
             <a:ext cx="502920" cy="201168"/>
           </a:xfrm>
           <a:prstGeom prst="rect">
@@ -4915,54 +5565,20 @@
                 </a:solidFill>
                 <a:latin typeface="Microsoft YaHei"/>
               </a:rPr>
-              <a:t>-0.75%</a:t>
-            </a:r>
-          </a:p>
-        </p:txBody>
-      </p:sp>
-      <p:sp>
-        <p:nvSpPr>
-          <p:cNvPr id="26" name="TextBox 25"/>
-          <p:cNvSpPr txBox="1"/>
-          <p:nvPr/>
-        </p:nvSpPr>
-        <p:spPr>
-          <a:xfrm>
-            <a:off x="4251960" y="1371600"/>
-            <a:ext cx="3383280" cy="219456"/>
-          </a:xfrm>
-          <a:prstGeom prst="rect">
-            <a:avLst/>
-          </a:prstGeom>
-          <a:noFill/>
-        </p:spPr>
-        <p:txBody>
-          <a:bodyPr wrap="none" lIns="18288" rIns="18288" tIns="18288" bIns="18288">
-            <a:spAutoFit/>
-          </a:bodyPr>
-          <a:lstStyle/>
-          <a:p>
-            <a:r>
-              <a:rPr sz="1100" b="1">
-                <a:solidFill>
-                  <a:srgbClr val="1A2026"/>
-                </a:solidFill>
-                <a:latin typeface="Microsoft YaHei"/>
-              </a:rPr>
-              <a:t>近1周收益</a:t>
-            </a:r>
-          </a:p>
-        </p:txBody>
-      </p:sp>
-      <p:sp>
-        <p:nvSpPr>
-          <p:cNvPr id="27" name="TextBox 26"/>
-          <p:cNvSpPr txBox="1"/>
-          <p:nvPr/>
-        </p:nvSpPr>
-        <p:spPr>
-          <a:xfrm>
-            <a:off x="4251960" y="1737360"/>
+              <a:t>-0.18%</a:t>
+            </a:r>
+          </a:p>
+        </p:txBody>
+      </p:sp>
+      <p:sp>
+        <p:nvSpPr>
+          <p:cNvPr id="43" name="TextBox 42"/>
+          <p:cNvSpPr txBox="1"/>
+          <p:nvPr/>
+        </p:nvSpPr>
+        <p:spPr>
+          <a:xfrm>
+            <a:off x="4251960" y="3273551"/>
             <a:ext cx="1078992" cy="201168"/>
           </a:xfrm>
           <a:prstGeom prst="rect">
@@ -4983,20 +5599,20 @@
                 </a:solidFill>
                 <a:latin typeface="Microsoft YaHei"/>
               </a:rPr>
-              <a:t>华夏沪深300E</a:t>
-            </a:r>
-          </a:p>
-        </p:txBody>
-      </p:sp>
-      <p:sp>
-        <p:nvSpPr>
-          <p:cNvPr id="28" name="Rectangle 27"/>
+              <a:t>易方达全球优质企</a:t>
+            </a:r>
+          </a:p>
+        </p:txBody>
+      </p:sp>
+      <p:sp>
+        <p:nvSpPr>
+          <p:cNvPr id="44" name="Rectangle 43"/>
           <p:cNvSpPr/>
           <p:nvPr/>
         </p:nvSpPr>
         <p:spPr>
           <a:xfrm>
-            <a:off x="6035040" y="1810512"/>
+            <a:off x="6035040" y="3346703"/>
             <a:ext cx="9144" cy="118872"/>
           </a:xfrm>
           <a:prstGeom prst="rect">
@@ -5033,14 +5649,14 @@
       </p:sp>
       <p:sp>
         <p:nvSpPr>
-          <p:cNvPr id="29" name="Rectangle 28"/>
+          <p:cNvPr id="45" name="Rectangle 44"/>
           <p:cNvSpPr/>
           <p:nvPr/>
         </p:nvSpPr>
         <p:spPr>
           <a:xfrm>
-            <a:off x="6035040" y="1792224"/>
-            <a:ext cx="1325880" cy="146304"/>
+            <a:off x="6035040" y="3328415"/>
+            <a:ext cx="587164" cy="146304"/>
           </a:xfrm>
           <a:prstGeom prst="rect">
             <a:avLst/>
@@ -5076,13 +5692,13 @@
       </p:sp>
       <p:sp>
         <p:nvSpPr>
-          <p:cNvPr id="30" name="TextBox 29"/>
-          <p:cNvSpPr txBox="1"/>
-          <p:nvPr/>
-        </p:nvSpPr>
-        <p:spPr>
-          <a:xfrm>
-            <a:off x="7406640" y="1746504"/>
+          <p:cNvPr id="46" name="TextBox 45"/>
+          <p:cNvSpPr txBox="1"/>
+          <p:nvPr/>
+        </p:nvSpPr>
+        <p:spPr>
+          <a:xfrm>
+            <a:off x="6667924" y="3282696"/>
             <a:ext cx="502920" cy="201168"/>
           </a:xfrm>
           <a:prstGeom prst="rect">
@@ -5103,20 +5719,54 @@
                 </a:solidFill>
                 <a:latin typeface="Microsoft YaHei"/>
               </a:rPr>
-              <a:t>1.37%</a:t>
-            </a:r>
-          </a:p>
-        </p:txBody>
-      </p:sp>
-      <p:sp>
-        <p:nvSpPr>
-          <p:cNvPr id="31" name="TextBox 30"/>
-          <p:cNvSpPr txBox="1"/>
-          <p:nvPr/>
-        </p:nvSpPr>
-        <p:spPr>
-          <a:xfrm>
-            <a:off x="4251960" y="2121408"/>
+              <a:t>0.87%</a:t>
+            </a:r>
+          </a:p>
+        </p:txBody>
+      </p:sp>
+      <p:sp>
+        <p:nvSpPr>
+          <p:cNvPr id="47" name="TextBox 46"/>
+          <p:cNvSpPr txBox="1"/>
+          <p:nvPr/>
+        </p:nvSpPr>
+        <p:spPr>
+          <a:xfrm>
+            <a:off x="7863840" y="1371600"/>
+            <a:ext cx="3383280" cy="219456"/>
+          </a:xfrm>
+          <a:prstGeom prst="rect">
+            <a:avLst/>
+          </a:prstGeom>
+          <a:noFill/>
+        </p:spPr>
+        <p:txBody>
+          <a:bodyPr wrap="none" lIns="18288" rIns="18288" tIns="18288" bIns="18288">
+            <a:spAutoFit/>
+          </a:bodyPr>
+          <a:lstStyle/>
+          <a:p>
+            <a:r>
+              <a:rPr sz="1100" b="1">
+                <a:solidFill>
+                  <a:srgbClr val="1A2026"/>
+                </a:solidFill>
+                <a:latin typeface="Microsoft YaHei"/>
+              </a:rPr>
+              <a:t>近1个月收益</a:t>
+            </a:r>
+          </a:p>
+        </p:txBody>
+      </p:sp>
+      <p:sp>
+        <p:nvSpPr>
+          <p:cNvPr id="48" name="TextBox 47"/>
+          <p:cNvSpPr txBox="1"/>
+          <p:nvPr/>
+        </p:nvSpPr>
+        <p:spPr>
+          <a:xfrm>
+            <a:off x="7863840" y="1737360"/>
             <a:ext cx="1078992" cy="201168"/>
           </a:xfrm>
           <a:prstGeom prst="rect">
@@ -5137,20 +5787,20 @@
                 </a:solidFill>
                 <a:latin typeface="Microsoft YaHei"/>
               </a:rPr>
-              <a:t>富国红利精选QD</a:t>
-            </a:r>
-          </a:p>
-        </p:txBody>
-      </p:sp>
-      <p:sp>
-        <p:nvSpPr>
-          <p:cNvPr id="32" name="Rectangle 31"/>
+              <a:t>华夏沪深300E</a:t>
+            </a:r>
+          </a:p>
+        </p:txBody>
+      </p:sp>
+      <p:sp>
+        <p:nvSpPr>
+          <p:cNvPr id="49" name="Rectangle 48"/>
           <p:cNvSpPr/>
           <p:nvPr/>
         </p:nvSpPr>
         <p:spPr>
           <a:xfrm>
-            <a:off x="6035040" y="2194560"/>
+            <a:off x="9646919" y="1810512"/>
             <a:ext cx="9144" cy="118872"/>
           </a:xfrm>
           <a:prstGeom prst="rect">
@@ -5187,14 +5837,14 @@
       </p:sp>
       <p:sp>
         <p:nvSpPr>
-          <p:cNvPr id="33" name="Rectangle 32"/>
+          <p:cNvPr id="50" name="Rectangle 49"/>
           <p:cNvSpPr/>
           <p:nvPr/>
         </p:nvSpPr>
         <p:spPr>
           <a:xfrm>
-            <a:off x="6035040" y="2176272"/>
-            <a:ext cx="1287222" cy="146304"/>
+            <a:off x="9646919" y="1792224"/>
+            <a:ext cx="614326" cy="146304"/>
           </a:xfrm>
           <a:prstGeom prst="rect">
             <a:avLst/>
@@ -5230,13 +5880,13 @@
       </p:sp>
       <p:sp>
         <p:nvSpPr>
-          <p:cNvPr id="34" name="TextBox 33"/>
-          <p:cNvSpPr txBox="1"/>
-          <p:nvPr/>
-        </p:nvSpPr>
-        <p:spPr>
-          <a:xfrm>
-            <a:off x="7367982" y="2130552"/>
+          <p:cNvPr id="51" name="TextBox 50"/>
+          <p:cNvSpPr txBox="1"/>
+          <p:nvPr/>
+        </p:nvSpPr>
+        <p:spPr>
+          <a:xfrm>
+            <a:off x="10306966" y="1746504"/>
             <a:ext cx="502920" cy="201168"/>
           </a:xfrm>
           <a:prstGeom prst="rect">
@@ -5257,20 +5907,20 @@
                 </a:solidFill>
                 <a:latin typeface="Microsoft YaHei"/>
               </a:rPr>
-              <a:t>1.33%</a:t>
-            </a:r>
-          </a:p>
-        </p:txBody>
-      </p:sp>
-      <p:sp>
-        <p:nvSpPr>
-          <p:cNvPr id="35" name="TextBox 34"/>
-          <p:cNvSpPr txBox="1"/>
-          <p:nvPr/>
-        </p:nvSpPr>
-        <p:spPr>
-          <a:xfrm>
-            <a:off x="4251960" y="2505456"/>
+              <a:t>1.60%</a:t>
+            </a:r>
+          </a:p>
+        </p:txBody>
+      </p:sp>
+      <p:sp>
+        <p:nvSpPr>
+          <p:cNvPr id="52" name="TextBox 51"/>
+          <p:cNvSpPr txBox="1"/>
+          <p:nvPr/>
+        </p:nvSpPr>
+        <p:spPr>
+          <a:xfrm>
+            <a:off x="7863840" y="2121408"/>
             <a:ext cx="1078992" cy="201168"/>
           </a:xfrm>
           <a:prstGeom prst="rect">
@@ -5291,20 +5941,20 @@
                 </a:solidFill>
                 <a:latin typeface="Microsoft YaHei"/>
               </a:rPr>
-              <a:t>纳斯达克100指</a:t>
-            </a:r>
-          </a:p>
-        </p:txBody>
-      </p:sp>
-      <p:sp>
-        <p:nvSpPr>
-          <p:cNvPr id="36" name="Rectangle 35"/>
+              <a:t>富国红利精选QD</a:t>
+            </a:r>
+          </a:p>
+        </p:txBody>
+      </p:sp>
+      <p:sp>
+        <p:nvSpPr>
+          <p:cNvPr id="53" name="Rectangle 52"/>
           <p:cNvSpPr/>
           <p:nvPr/>
         </p:nvSpPr>
         <p:spPr>
           <a:xfrm>
-            <a:off x="6035040" y="2578608"/>
+            <a:off x="9646919" y="2194560"/>
             <a:ext cx="9144" cy="118872"/>
           </a:xfrm>
           <a:prstGeom prst="rect">
@@ -5341,14 +5991,14 @@
       </p:sp>
       <p:sp>
         <p:nvSpPr>
-          <p:cNvPr id="37" name="Rectangle 36"/>
+          <p:cNvPr id="54" name="Rectangle 53"/>
           <p:cNvSpPr/>
           <p:nvPr/>
         </p:nvSpPr>
         <p:spPr>
           <a:xfrm>
-            <a:off x="6035040" y="2560320"/>
-            <a:ext cx="346783" cy="146304"/>
+            <a:off x="9646919" y="2176272"/>
+            <a:ext cx="979480" cy="146304"/>
           </a:xfrm>
           <a:prstGeom prst="rect">
             <a:avLst/>
@@ -5384,13 +6034,13 @@
       </p:sp>
       <p:sp>
         <p:nvSpPr>
-          <p:cNvPr id="38" name="TextBox 37"/>
-          <p:cNvSpPr txBox="1"/>
-          <p:nvPr/>
-        </p:nvSpPr>
-        <p:spPr>
-          <a:xfrm>
-            <a:off x="6427543" y="2514600"/>
+          <p:cNvPr id="55" name="TextBox 54"/>
+          <p:cNvSpPr txBox="1"/>
+          <p:nvPr/>
+        </p:nvSpPr>
+        <p:spPr>
+          <a:xfrm>
+            <a:off x="10672120" y="2130552"/>
             <a:ext cx="502920" cy="201168"/>
           </a:xfrm>
           <a:prstGeom prst="rect">
@@ -5411,20 +6061,20 @@
                 </a:solidFill>
                 <a:latin typeface="Microsoft YaHei"/>
               </a:rPr>
-              <a:t>0.36%</a:t>
-            </a:r>
-          </a:p>
-        </p:txBody>
-      </p:sp>
-      <p:sp>
-        <p:nvSpPr>
-          <p:cNvPr id="39" name="TextBox 38"/>
-          <p:cNvSpPr txBox="1"/>
-          <p:nvPr/>
-        </p:nvSpPr>
-        <p:spPr>
-          <a:xfrm>
-            <a:off x="4251960" y="2889503"/>
+              <a:t>2.56%</a:t>
+            </a:r>
+          </a:p>
+        </p:txBody>
+      </p:sp>
+      <p:sp>
+        <p:nvSpPr>
+          <p:cNvPr id="56" name="TextBox 55"/>
+          <p:cNvSpPr txBox="1"/>
+          <p:nvPr/>
+        </p:nvSpPr>
+        <p:spPr>
+          <a:xfrm>
+            <a:off x="7863840" y="2505456"/>
             <a:ext cx="1078992" cy="201168"/>
           </a:xfrm>
           <a:prstGeom prst="rect">
@@ -5445,20 +6095,20 @@
                 </a:solidFill>
                 <a:latin typeface="Microsoft YaHei"/>
               </a:rPr>
-              <a:t>兴全安泰积极养老</a:t>
-            </a:r>
-          </a:p>
-        </p:txBody>
-      </p:sp>
-      <p:sp>
-        <p:nvSpPr>
-          <p:cNvPr id="40" name="Rectangle 39"/>
+              <a:t>纳斯达克100指</a:t>
+            </a:r>
+          </a:p>
+        </p:txBody>
+      </p:sp>
+      <p:sp>
+        <p:nvSpPr>
+          <p:cNvPr id="57" name="Rectangle 56"/>
           <p:cNvSpPr/>
           <p:nvPr/>
         </p:nvSpPr>
         <p:spPr>
           <a:xfrm>
-            <a:off x="6035040" y="2962656"/>
+            <a:off x="9646919" y="2578608"/>
             <a:ext cx="9144" cy="118872"/>
           </a:xfrm>
           <a:prstGeom prst="rect">
@@ -5495,14 +6145,14 @@
       </p:sp>
       <p:sp>
         <p:nvSpPr>
-          <p:cNvPr id="41" name="Rectangle 40"/>
+          <p:cNvPr id="58" name="Rectangle 57"/>
           <p:cNvSpPr/>
           <p:nvPr/>
         </p:nvSpPr>
         <p:spPr>
           <a:xfrm>
-            <a:off x="6035040" y="2944368"/>
-            <a:ext cx="201372" cy="146304"/>
+            <a:off x="9646919" y="2560320"/>
+            <a:ext cx="1325880" cy="146304"/>
           </a:xfrm>
           <a:prstGeom prst="rect">
             <a:avLst/>
@@ -5538,13 +6188,13 @@
       </p:sp>
       <p:sp>
         <p:nvSpPr>
-          <p:cNvPr id="42" name="TextBox 41"/>
-          <p:cNvSpPr txBox="1"/>
-          <p:nvPr/>
-        </p:nvSpPr>
-        <p:spPr>
-          <a:xfrm>
-            <a:off x="6282132" y="2898648"/>
+          <p:cNvPr id="59" name="TextBox 58"/>
+          <p:cNvSpPr txBox="1"/>
+          <p:nvPr/>
+        </p:nvSpPr>
+        <p:spPr>
+          <a:xfrm>
+            <a:off x="11018519" y="2514600"/>
             <a:ext cx="502920" cy="201168"/>
           </a:xfrm>
           <a:prstGeom prst="rect">
@@ -5565,20 +6215,20 @@
                 </a:solidFill>
                 <a:latin typeface="Microsoft YaHei"/>
               </a:rPr>
-              <a:t>0.21%</a:t>
-            </a:r>
-          </a:p>
-        </p:txBody>
-      </p:sp>
-      <p:sp>
-        <p:nvSpPr>
-          <p:cNvPr id="43" name="TextBox 42"/>
-          <p:cNvSpPr txBox="1"/>
-          <p:nvPr/>
-        </p:nvSpPr>
-        <p:spPr>
-          <a:xfrm>
-            <a:off x="4251960" y="3273551"/>
+              <a:t>3.46%</a:t>
+            </a:r>
+          </a:p>
+        </p:txBody>
+      </p:sp>
+      <p:sp>
+        <p:nvSpPr>
+          <p:cNvPr id="60" name="TextBox 59"/>
+          <p:cNvSpPr txBox="1"/>
+          <p:nvPr/>
+        </p:nvSpPr>
+        <p:spPr>
+          <a:xfrm>
+            <a:off x="7863840" y="2889503"/>
             <a:ext cx="1078992" cy="201168"/>
           </a:xfrm>
           <a:prstGeom prst="rect">
@@ -5599,20 +6249,20 @@
                 </a:solidFill>
                 <a:latin typeface="Microsoft YaHei"/>
               </a:rPr>
-              <a:t>易方达全球优质企</a:t>
-            </a:r>
-          </a:p>
-        </p:txBody>
-      </p:sp>
-      <p:sp>
-        <p:nvSpPr>
-          <p:cNvPr id="44" name="Rectangle 43"/>
+              <a:t>兴全安泰积极养老</a:t>
+            </a:r>
+          </a:p>
+        </p:txBody>
+      </p:sp>
+      <p:sp>
+        <p:nvSpPr>
+          <p:cNvPr id="61" name="Rectangle 60"/>
           <p:cNvSpPr/>
           <p:nvPr/>
         </p:nvSpPr>
         <p:spPr>
           <a:xfrm>
-            <a:off x="6035040" y="3346703"/>
+            <a:off x="9646919" y="2962656"/>
             <a:ext cx="9144" cy="118872"/>
           </a:xfrm>
           <a:prstGeom prst="rect">
@@ -5649,20 +6299,20 @@
       </p:sp>
       <p:sp>
         <p:nvSpPr>
-          <p:cNvPr id="45" name="Rectangle 44"/>
+          <p:cNvPr id="62" name="Rectangle 61"/>
           <p:cNvSpPr/>
           <p:nvPr/>
         </p:nvSpPr>
         <p:spPr>
           <a:xfrm>
-            <a:off x="5280738" y="3328415"/>
-            <a:ext cx="754301" cy="146304"/>
+            <a:off x="9646919" y="2944368"/>
+            <a:ext cx="1159673" cy="146304"/>
           </a:xfrm>
           <a:prstGeom prst="rect">
             <a:avLst/>
           </a:prstGeom>
           <a:solidFill>
-            <a:srgbClr val="BF4040"/>
+            <a:srgbClr val="198974"/>
           </a:solidFill>
           <a:ln>
             <a:noFill/>
@@ -5692,13 +6342,13 @@
       </p:sp>
       <p:sp>
         <p:nvSpPr>
-          <p:cNvPr id="46" name="TextBox 45"/>
-          <p:cNvSpPr txBox="1"/>
-          <p:nvPr/>
-        </p:nvSpPr>
-        <p:spPr>
-          <a:xfrm>
-            <a:off x="6080760" y="3282696"/>
+          <p:cNvPr id="63" name="TextBox 62"/>
+          <p:cNvSpPr txBox="1"/>
+          <p:nvPr/>
+        </p:nvSpPr>
+        <p:spPr>
+          <a:xfrm>
+            <a:off x="10852313" y="2898648"/>
             <a:ext cx="502920" cy="201168"/>
           </a:xfrm>
           <a:prstGeom prst="rect">
@@ -5719,54 +6369,20 @@
                 </a:solidFill>
                 <a:latin typeface="Microsoft YaHei"/>
               </a:rPr>
-              <a:t>-0.78%</a:t>
-            </a:r>
-          </a:p>
-        </p:txBody>
-      </p:sp>
-      <p:sp>
-        <p:nvSpPr>
-          <p:cNvPr id="47" name="TextBox 46"/>
-          <p:cNvSpPr txBox="1"/>
-          <p:nvPr/>
-        </p:nvSpPr>
-        <p:spPr>
-          <a:xfrm>
-            <a:off x="7863840" y="1371600"/>
-            <a:ext cx="3383280" cy="219456"/>
-          </a:xfrm>
-          <a:prstGeom prst="rect">
-            <a:avLst/>
-          </a:prstGeom>
-          <a:noFill/>
-        </p:spPr>
-        <p:txBody>
-          <a:bodyPr wrap="none" lIns="18288" rIns="18288" tIns="18288" bIns="18288">
-            <a:spAutoFit/>
-          </a:bodyPr>
-          <a:lstStyle/>
-          <a:p>
-            <a:r>
-              <a:rPr sz="1100" b="1">
-                <a:solidFill>
-                  <a:srgbClr val="1A2026"/>
-                </a:solidFill>
-                <a:latin typeface="Microsoft YaHei"/>
-              </a:rPr>
-              <a:t>近1个月收益</a:t>
-            </a:r>
-          </a:p>
-        </p:txBody>
-      </p:sp>
-      <p:sp>
-        <p:nvSpPr>
-          <p:cNvPr id="48" name="TextBox 47"/>
-          <p:cNvSpPr txBox="1"/>
-          <p:nvPr/>
-        </p:nvSpPr>
-        <p:spPr>
-          <a:xfrm>
-            <a:off x="7863840" y="1737360"/>
+              <a:t>3.03%</a:t>
+            </a:r>
+          </a:p>
+        </p:txBody>
+      </p:sp>
+      <p:sp>
+        <p:nvSpPr>
+          <p:cNvPr id="64" name="TextBox 63"/>
+          <p:cNvSpPr txBox="1"/>
+          <p:nvPr/>
+        </p:nvSpPr>
+        <p:spPr>
+          <a:xfrm>
+            <a:off x="7863840" y="3273551"/>
             <a:ext cx="1078992" cy="201168"/>
           </a:xfrm>
           <a:prstGeom prst="rect">
@@ -5787,20 +6403,20 @@
                 </a:solidFill>
                 <a:latin typeface="Microsoft YaHei"/>
               </a:rPr>
-              <a:t>华夏沪深300E</a:t>
-            </a:r>
-          </a:p>
-        </p:txBody>
-      </p:sp>
-      <p:sp>
-        <p:nvSpPr>
-          <p:cNvPr id="49" name="Rectangle 48"/>
+              <a:t>易方达全球优质企</a:t>
+            </a:r>
+          </a:p>
+        </p:txBody>
+      </p:sp>
+      <p:sp>
+        <p:nvSpPr>
+          <p:cNvPr id="65" name="Rectangle 64"/>
           <p:cNvSpPr/>
           <p:nvPr/>
         </p:nvSpPr>
         <p:spPr>
           <a:xfrm>
-            <a:off x="9646919" y="1810512"/>
+            <a:off x="9646919" y="3346703"/>
             <a:ext cx="9144" cy="118872"/>
           </a:xfrm>
           <a:prstGeom prst="rect">
@@ -5837,14 +6453,14 @@
       </p:sp>
       <p:sp>
         <p:nvSpPr>
-          <p:cNvPr id="50" name="Rectangle 49"/>
+          <p:cNvPr id="66" name="Rectangle 65"/>
           <p:cNvSpPr/>
           <p:nvPr/>
         </p:nvSpPr>
         <p:spPr>
           <a:xfrm>
-            <a:off x="9646919" y="1792224"/>
-            <a:ext cx="329112" cy="146304"/>
+            <a:off x="9646919" y="3328415"/>
+            <a:ext cx="265246" cy="146304"/>
           </a:xfrm>
           <a:prstGeom prst="rect">
             <a:avLst/>
@@ -5880,13 +6496,13 @@
       </p:sp>
       <p:sp>
         <p:nvSpPr>
-          <p:cNvPr id="51" name="TextBox 50"/>
-          <p:cNvSpPr txBox="1"/>
-          <p:nvPr/>
-        </p:nvSpPr>
-        <p:spPr>
-          <a:xfrm>
-            <a:off x="10021752" y="1746504"/>
+          <p:cNvPr id="67" name="TextBox 66"/>
+          <p:cNvSpPr txBox="1"/>
+          <p:nvPr/>
+        </p:nvSpPr>
+        <p:spPr>
+          <a:xfrm>
+            <a:off x="9957886" y="3282696"/>
             <a:ext cx="502920" cy="201168"/>
           </a:xfrm>
           <a:prstGeom prst="rect">
@@ -5907,623 +6523,7 @@
                 </a:solidFill>
                 <a:latin typeface="Microsoft YaHei"/>
               </a:rPr>
-              <a:t>0.95%</a:t>
-            </a:r>
-          </a:p>
-        </p:txBody>
-      </p:sp>
-      <p:sp>
-        <p:nvSpPr>
-          <p:cNvPr id="52" name="TextBox 51"/>
-          <p:cNvSpPr txBox="1"/>
-          <p:nvPr/>
-        </p:nvSpPr>
-        <p:spPr>
-          <a:xfrm>
-            <a:off x="7863840" y="2121408"/>
-            <a:ext cx="1078992" cy="201168"/>
-          </a:xfrm>
-          <a:prstGeom prst="rect">
-            <a:avLst/>
-          </a:prstGeom>
-          <a:noFill/>
-        </p:spPr>
-        <p:txBody>
-          <a:bodyPr wrap="none" lIns="18288" rIns="18288" tIns="18288" bIns="18288">
-            <a:spAutoFit/>
-          </a:bodyPr>
-          <a:lstStyle/>
-          <a:p>
-            <a:r>
-              <a:rPr sz="800" b="0">
-                <a:solidFill>
-                  <a:srgbClr val="65707D"/>
-                </a:solidFill>
-                <a:latin typeface="Microsoft YaHei"/>
-              </a:rPr>
-              <a:t>富国红利精选QD</a:t>
-            </a:r>
-          </a:p>
-        </p:txBody>
-      </p:sp>
-      <p:sp>
-        <p:nvSpPr>
-          <p:cNvPr id="53" name="Rectangle 52"/>
-          <p:cNvSpPr/>
-          <p:nvPr/>
-        </p:nvSpPr>
-        <p:spPr>
-          <a:xfrm>
-            <a:off x="9646919" y="2194560"/>
-            <a:ext cx="9144" cy="118872"/>
-          </a:xfrm>
-          <a:prstGeom prst="rect">
-            <a:avLst/>
-          </a:prstGeom>
-          <a:solidFill>
-            <a:srgbClr val="DAD5C9"/>
-          </a:solidFill>
-          <a:ln>
-            <a:noFill/>
-          </a:ln>
-        </p:spPr>
-        <p:style>
-          <a:lnRef idx="1">
-            <a:schemeClr val="accent1"/>
-          </a:lnRef>
-          <a:fillRef idx="3">
-            <a:schemeClr val="accent1"/>
-          </a:fillRef>
-          <a:effectRef idx="2">
-            <a:schemeClr val="accent1"/>
-          </a:effectRef>
-          <a:fontRef idx="minor">
-            <a:schemeClr val="lt1"/>
-          </a:fontRef>
-        </p:style>
-        <p:txBody>
-          <a:bodyPr rtlCol="0" anchor="ctr"/>
-          <a:lstStyle/>
-          <a:p>
-            <a:pPr algn="ctr"/>
-          </a:p>
-        </p:txBody>
-      </p:sp>
-      <p:sp>
-        <p:nvSpPr>
-          <p:cNvPr id="54" name="Rectangle 53"/>
-          <p:cNvSpPr/>
-          <p:nvPr/>
-        </p:nvSpPr>
-        <p:spPr>
-          <a:xfrm>
-            <a:off x="9646919" y="2176272"/>
-            <a:ext cx="940036" cy="146304"/>
-          </a:xfrm>
-          <a:prstGeom prst="rect">
-            <a:avLst/>
-          </a:prstGeom>
-          <a:solidFill>
-            <a:srgbClr val="198974"/>
-          </a:solidFill>
-          <a:ln>
-            <a:noFill/>
-          </a:ln>
-        </p:spPr>
-        <p:style>
-          <a:lnRef idx="1">
-            <a:schemeClr val="accent1"/>
-          </a:lnRef>
-          <a:fillRef idx="3">
-            <a:schemeClr val="accent1"/>
-          </a:fillRef>
-          <a:effectRef idx="2">
-            <a:schemeClr val="accent1"/>
-          </a:effectRef>
-          <a:fontRef idx="minor">
-            <a:schemeClr val="lt1"/>
-          </a:fontRef>
-        </p:style>
-        <p:txBody>
-          <a:bodyPr rtlCol="0" anchor="ctr"/>
-          <a:lstStyle/>
-          <a:p>
-            <a:pPr algn="ctr"/>
-          </a:p>
-        </p:txBody>
-      </p:sp>
-      <p:sp>
-        <p:nvSpPr>
-          <p:cNvPr id="55" name="TextBox 54"/>
-          <p:cNvSpPr txBox="1"/>
-          <p:nvPr/>
-        </p:nvSpPr>
-        <p:spPr>
-          <a:xfrm>
-            <a:off x="10632676" y="2130552"/>
-            <a:ext cx="502920" cy="201168"/>
-          </a:xfrm>
-          <a:prstGeom prst="rect">
-            <a:avLst/>
-          </a:prstGeom>
-          <a:noFill/>
-        </p:spPr>
-        <p:txBody>
-          <a:bodyPr wrap="none" lIns="18288" rIns="18288" tIns="18288" bIns="18288">
-            <a:spAutoFit/>
-          </a:bodyPr>
-          <a:lstStyle/>
-          <a:p>
-            <a:r>
-              <a:rPr sz="800" b="0">
-                <a:solidFill>
-                  <a:srgbClr val="1A2026"/>
-                </a:solidFill>
-                <a:latin typeface="Microsoft YaHei"/>
-              </a:rPr>
-              <a:t>2.72%</a:t>
-            </a:r>
-          </a:p>
-        </p:txBody>
-      </p:sp>
-      <p:sp>
-        <p:nvSpPr>
-          <p:cNvPr id="56" name="TextBox 55"/>
-          <p:cNvSpPr txBox="1"/>
-          <p:nvPr/>
-        </p:nvSpPr>
-        <p:spPr>
-          <a:xfrm>
-            <a:off x="7863840" y="2505456"/>
-            <a:ext cx="1078992" cy="201168"/>
-          </a:xfrm>
-          <a:prstGeom prst="rect">
-            <a:avLst/>
-          </a:prstGeom>
-          <a:noFill/>
-        </p:spPr>
-        <p:txBody>
-          <a:bodyPr wrap="none" lIns="18288" rIns="18288" tIns="18288" bIns="18288">
-            <a:spAutoFit/>
-          </a:bodyPr>
-          <a:lstStyle/>
-          <a:p>
-            <a:r>
-              <a:rPr sz="800" b="0">
-                <a:solidFill>
-                  <a:srgbClr val="65707D"/>
-                </a:solidFill>
-                <a:latin typeface="Microsoft YaHei"/>
-              </a:rPr>
-              <a:t>纳斯达克100指</a:t>
-            </a:r>
-          </a:p>
-        </p:txBody>
-      </p:sp>
-      <p:sp>
-        <p:nvSpPr>
-          <p:cNvPr id="57" name="Rectangle 56"/>
-          <p:cNvSpPr/>
-          <p:nvPr/>
-        </p:nvSpPr>
-        <p:spPr>
-          <a:xfrm>
-            <a:off x="9646919" y="2578608"/>
-            <a:ext cx="9144" cy="118872"/>
-          </a:xfrm>
-          <a:prstGeom prst="rect">
-            <a:avLst/>
-          </a:prstGeom>
-          <a:solidFill>
-            <a:srgbClr val="DAD5C9"/>
-          </a:solidFill>
-          <a:ln>
-            <a:noFill/>
-          </a:ln>
-        </p:spPr>
-        <p:style>
-          <a:lnRef idx="1">
-            <a:schemeClr val="accent1"/>
-          </a:lnRef>
-          <a:fillRef idx="3">
-            <a:schemeClr val="accent1"/>
-          </a:fillRef>
-          <a:effectRef idx="2">
-            <a:schemeClr val="accent1"/>
-          </a:effectRef>
-          <a:fontRef idx="minor">
-            <a:schemeClr val="lt1"/>
-          </a:fontRef>
-        </p:style>
-        <p:txBody>
-          <a:bodyPr rtlCol="0" anchor="ctr"/>
-          <a:lstStyle/>
-          <a:p>
-            <a:pPr algn="ctr"/>
-          </a:p>
-        </p:txBody>
-      </p:sp>
-      <p:sp>
-        <p:nvSpPr>
-          <p:cNvPr id="58" name="Rectangle 57"/>
-          <p:cNvSpPr/>
-          <p:nvPr/>
-        </p:nvSpPr>
-        <p:spPr>
-          <a:xfrm>
-            <a:off x="9646919" y="2560320"/>
-            <a:ext cx="1325880" cy="146304"/>
-          </a:xfrm>
-          <a:prstGeom prst="rect">
-            <a:avLst/>
-          </a:prstGeom>
-          <a:solidFill>
-            <a:srgbClr val="198974"/>
-          </a:solidFill>
-          <a:ln>
-            <a:noFill/>
-          </a:ln>
-        </p:spPr>
-        <p:style>
-          <a:lnRef idx="1">
-            <a:schemeClr val="accent1"/>
-          </a:lnRef>
-          <a:fillRef idx="3">
-            <a:schemeClr val="accent1"/>
-          </a:fillRef>
-          <a:effectRef idx="2">
-            <a:schemeClr val="accent1"/>
-          </a:effectRef>
-          <a:fontRef idx="minor">
-            <a:schemeClr val="lt1"/>
-          </a:fontRef>
-        </p:style>
-        <p:txBody>
-          <a:bodyPr rtlCol="0" anchor="ctr"/>
-          <a:lstStyle/>
-          <a:p>
-            <a:pPr algn="ctr"/>
-          </a:p>
-        </p:txBody>
-      </p:sp>
-      <p:sp>
-        <p:nvSpPr>
-          <p:cNvPr id="59" name="TextBox 58"/>
-          <p:cNvSpPr txBox="1"/>
-          <p:nvPr/>
-        </p:nvSpPr>
-        <p:spPr>
-          <a:xfrm>
-            <a:off x="11018519" y="2514600"/>
-            <a:ext cx="502920" cy="201168"/>
-          </a:xfrm>
-          <a:prstGeom prst="rect">
-            <a:avLst/>
-          </a:prstGeom>
-          <a:noFill/>
-        </p:spPr>
-        <p:txBody>
-          <a:bodyPr wrap="none" lIns="18288" rIns="18288" tIns="18288" bIns="18288">
-            <a:spAutoFit/>
-          </a:bodyPr>
-          <a:lstStyle/>
-          <a:p>
-            <a:r>
-              <a:rPr sz="800" b="0">
-                <a:solidFill>
-                  <a:srgbClr val="1A2026"/>
-                </a:solidFill>
-                <a:latin typeface="Microsoft YaHei"/>
-              </a:rPr>
-              <a:t>3.84%</a:t>
-            </a:r>
-          </a:p>
-        </p:txBody>
-      </p:sp>
-      <p:sp>
-        <p:nvSpPr>
-          <p:cNvPr id="60" name="TextBox 59"/>
-          <p:cNvSpPr txBox="1"/>
-          <p:nvPr/>
-        </p:nvSpPr>
-        <p:spPr>
-          <a:xfrm>
-            <a:off x="7863840" y="2889503"/>
-            <a:ext cx="1078992" cy="201168"/>
-          </a:xfrm>
-          <a:prstGeom prst="rect">
-            <a:avLst/>
-          </a:prstGeom>
-          <a:noFill/>
-        </p:spPr>
-        <p:txBody>
-          <a:bodyPr wrap="none" lIns="18288" rIns="18288" tIns="18288" bIns="18288">
-            <a:spAutoFit/>
-          </a:bodyPr>
-          <a:lstStyle/>
-          <a:p>
-            <a:r>
-              <a:rPr sz="800" b="0">
-                <a:solidFill>
-                  <a:srgbClr val="65707D"/>
-                </a:solidFill>
-                <a:latin typeface="Microsoft YaHei"/>
-              </a:rPr>
-              <a:t>兴全安泰积极养老</a:t>
-            </a:r>
-          </a:p>
-        </p:txBody>
-      </p:sp>
-      <p:sp>
-        <p:nvSpPr>
-          <p:cNvPr id="61" name="Rectangle 60"/>
-          <p:cNvSpPr/>
-          <p:nvPr/>
-        </p:nvSpPr>
-        <p:spPr>
-          <a:xfrm>
-            <a:off x="9646919" y="2962656"/>
-            <a:ext cx="9144" cy="118872"/>
-          </a:xfrm>
-          <a:prstGeom prst="rect">
-            <a:avLst/>
-          </a:prstGeom>
-          <a:solidFill>
-            <a:srgbClr val="DAD5C9"/>
-          </a:solidFill>
-          <a:ln>
-            <a:noFill/>
-          </a:ln>
-        </p:spPr>
-        <p:style>
-          <a:lnRef idx="1">
-            <a:schemeClr val="accent1"/>
-          </a:lnRef>
-          <a:fillRef idx="3">
-            <a:schemeClr val="accent1"/>
-          </a:fillRef>
-          <a:effectRef idx="2">
-            <a:schemeClr val="accent1"/>
-          </a:effectRef>
-          <a:fontRef idx="minor">
-            <a:schemeClr val="lt1"/>
-          </a:fontRef>
-        </p:style>
-        <p:txBody>
-          <a:bodyPr rtlCol="0" anchor="ctr"/>
-          <a:lstStyle/>
-          <a:p>
-            <a:pPr algn="ctr"/>
-          </a:p>
-        </p:txBody>
-      </p:sp>
-      <p:sp>
-        <p:nvSpPr>
-          <p:cNvPr id="62" name="Rectangle 61"/>
-          <p:cNvSpPr/>
-          <p:nvPr/>
-        </p:nvSpPr>
-        <p:spPr>
-          <a:xfrm>
-            <a:off x="9646919" y="2944368"/>
-            <a:ext cx="720277" cy="146304"/>
-          </a:xfrm>
-          <a:prstGeom prst="rect">
-            <a:avLst/>
-          </a:prstGeom>
-          <a:solidFill>
-            <a:srgbClr val="198974"/>
-          </a:solidFill>
-          <a:ln>
-            <a:noFill/>
-          </a:ln>
-        </p:spPr>
-        <p:style>
-          <a:lnRef idx="1">
-            <a:schemeClr val="accent1"/>
-          </a:lnRef>
-          <a:fillRef idx="3">
-            <a:schemeClr val="accent1"/>
-          </a:fillRef>
-          <a:effectRef idx="2">
-            <a:schemeClr val="accent1"/>
-          </a:effectRef>
-          <a:fontRef idx="minor">
-            <a:schemeClr val="lt1"/>
-          </a:fontRef>
-        </p:style>
-        <p:txBody>
-          <a:bodyPr rtlCol="0" anchor="ctr"/>
-          <a:lstStyle/>
-          <a:p>
-            <a:pPr algn="ctr"/>
-          </a:p>
-        </p:txBody>
-      </p:sp>
-      <p:sp>
-        <p:nvSpPr>
-          <p:cNvPr id="63" name="TextBox 62"/>
-          <p:cNvSpPr txBox="1"/>
-          <p:nvPr/>
-        </p:nvSpPr>
-        <p:spPr>
-          <a:xfrm>
-            <a:off x="10412917" y="2898648"/>
-            <a:ext cx="502920" cy="201168"/>
-          </a:xfrm>
-          <a:prstGeom prst="rect">
-            <a:avLst/>
-          </a:prstGeom>
-          <a:noFill/>
-        </p:spPr>
-        <p:txBody>
-          <a:bodyPr wrap="none" lIns="18288" rIns="18288" tIns="18288" bIns="18288">
-            <a:spAutoFit/>
-          </a:bodyPr>
-          <a:lstStyle/>
-          <a:p>
-            <a:r>
-              <a:rPr sz="800" b="0">
-                <a:solidFill>
-                  <a:srgbClr val="1A2026"/>
-                </a:solidFill>
-                <a:latin typeface="Microsoft YaHei"/>
-              </a:rPr>
-              <a:t>2.09%</a:t>
-            </a:r>
-          </a:p>
-        </p:txBody>
-      </p:sp>
-      <p:sp>
-        <p:nvSpPr>
-          <p:cNvPr id="64" name="TextBox 63"/>
-          <p:cNvSpPr txBox="1"/>
-          <p:nvPr/>
-        </p:nvSpPr>
-        <p:spPr>
-          <a:xfrm>
-            <a:off x="7863840" y="3273551"/>
-            <a:ext cx="1078992" cy="201168"/>
-          </a:xfrm>
-          <a:prstGeom prst="rect">
-            <a:avLst/>
-          </a:prstGeom>
-          <a:noFill/>
-        </p:spPr>
-        <p:txBody>
-          <a:bodyPr wrap="none" lIns="18288" rIns="18288" tIns="18288" bIns="18288">
-            <a:spAutoFit/>
-          </a:bodyPr>
-          <a:lstStyle/>
-          <a:p>
-            <a:r>
-              <a:rPr sz="800" b="0">
-                <a:solidFill>
-                  <a:srgbClr val="65707D"/>
-                </a:solidFill>
-                <a:latin typeface="Microsoft YaHei"/>
-              </a:rPr>
-              <a:t>易方达全球优质企</a:t>
-            </a:r>
-          </a:p>
-        </p:txBody>
-      </p:sp>
-      <p:sp>
-        <p:nvSpPr>
-          <p:cNvPr id="65" name="Rectangle 64"/>
-          <p:cNvSpPr/>
-          <p:nvPr/>
-        </p:nvSpPr>
-        <p:spPr>
-          <a:xfrm>
-            <a:off x="9646919" y="3346703"/>
-            <a:ext cx="9144" cy="118872"/>
-          </a:xfrm>
-          <a:prstGeom prst="rect">
-            <a:avLst/>
-          </a:prstGeom>
-          <a:solidFill>
-            <a:srgbClr val="DAD5C9"/>
-          </a:solidFill>
-          <a:ln>
-            <a:noFill/>
-          </a:ln>
-        </p:spPr>
-        <p:style>
-          <a:lnRef idx="1">
-            <a:schemeClr val="accent1"/>
-          </a:lnRef>
-          <a:fillRef idx="3">
-            <a:schemeClr val="accent1"/>
-          </a:fillRef>
-          <a:effectRef idx="2">
-            <a:schemeClr val="accent1"/>
-          </a:effectRef>
-          <a:fontRef idx="minor">
-            <a:schemeClr val="lt1"/>
-          </a:fontRef>
-        </p:style>
-        <p:txBody>
-          <a:bodyPr rtlCol="0" anchor="ctr"/>
-          <a:lstStyle/>
-          <a:p>
-            <a:pPr algn="ctr"/>
-          </a:p>
-        </p:txBody>
-      </p:sp>
-      <p:sp>
-        <p:nvSpPr>
-          <p:cNvPr id="66" name="Rectangle 65"/>
-          <p:cNvSpPr/>
-          <p:nvPr/>
-        </p:nvSpPr>
-        <p:spPr>
-          <a:xfrm>
-            <a:off x="9580397" y="3328415"/>
-            <a:ext cx="66522" cy="146304"/>
-          </a:xfrm>
-          <a:prstGeom prst="rect">
-            <a:avLst/>
-          </a:prstGeom>
-          <a:solidFill>
-            <a:srgbClr val="BF4040"/>
-          </a:solidFill>
-          <a:ln>
-            <a:noFill/>
-          </a:ln>
-        </p:spPr>
-        <p:style>
-          <a:lnRef idx="1">
-            <a:schemeClr val="accent1"/>
-          </a:lnRef>
-          <a:fillRef idx="3">
-            <a:schemeClr val="accent1"/>
-          </a:fillRef>
-          <a:effectRef idx="2">
-            <a:schemeClr val="accent1"/>
-          </a:effectRef>
-          <a:fontRef idx="minor">
-            <a:schemeClr val="lt1"/>
-          </a:fontRef>
-        </p:style>
-        <p:txBody>
-          <a:bodyPr rtlCol="0" anchor="ctr"/>
-          <a:lstStyle/>
-          <a:p>
-            <a:pPr algn="ctr"/>
-          </a:p>
-        </p:txBody>
-      </p:sp>
-      <p:sp>
-        <p:nvSpPr>
-          <p:cNvPr id="67" name="TextBox 66"/>
-          <p:cNvSpPr txBox="1"/>
-          <p:nvPr/>
-        </p:nvSpPr>
-        <p:spPr>
-          <a:xfrm>
-            <a:off x="9692640" y="3282696"/>
-            <a:ext cx="502920" cy="201168"/>
-          </a:xfrm>
-          <a:prstGeom prst="rect">
-            <a:avLst/>
-          </a:prstGeom>
-          <a:noFill/>
-        </p:spPr>
-        <p:txBody>
-          <a:bodyPr wrap="none" lIns="18288" rIns="18288" tIns="18288" bIns="18288">
-            <a:spAutoFit/>
-          </a:bodyPr>
-          <a:lstStyle/>
-          <a:p>
-            <a:r>
-              <a:rPr sz="800" b="0">
-                <a:solidFill>
-                  <a:srgbClr val="1A2026"/>
-                </a:solidFill>
-                <a:latin typeface="Microsoft YaHei"/>
-              </a:rPr>
-              <a:t>-0.19%</a:t>
+              <a:t>0.69%</a:t>
             </a:r>
           </a:p>
         </p:txBody>
@@ -6761,7 +6761,7 @@
                 </a:solidFill>
                 <a:latin typeface="Microsoft YaHei"/>
               </a:rPr>
-              <a:t>1.7672</a:t>
+              <a:t>1.7623</a:t>
             </a:r>
           </a:p>
         </p:txBody>
@@ -6795,7 +6795,7 @@
                 </a:solidFill>
                 <a:latin typeface="Microsoft YaHei"/>
               </a:rPr>
-              <a:t>2026-08-31</a:t>
+              <a:t>2026-09-01</a:t>
             </a:r>
           </a:p>
         </p:txBody>
@@ -6897,7 +6897,7 @@
                 </a:solidFill>
                 <a:latin typeface="Microsoft YaHei"/>
               </a:rPr>
-              <a:t>1.9113</a:t>
+              <a:t>1.9143</a:t>
             </a:r>
           </a:p>
         </p:txBody>
@@ -6931,7 +6931,7 @@
                 </a:solidFill>
                 <a:latin typeface="Microsoft YaHei"/>
               </a:rPr>
-              <a:t>2026-08-28</a:t>
+              <a:t>2026-08-31</a:t>
             </a:r>
           </a:p>
         </p:txBody>
@@ -7033,7 +7033,7 @@
                 </a:solidFill>
                 <a:latin typeface="Microsoft YaHei"/>
               </a:rPr>
-              <a:t>2.0237</a:t>
+              <a:t>2.0248</a:t>
             </a:r>
           </a:p>
         </p:txBody>
@@ -7067,7 +7067,7 @@
                 </a:solidFill>
                 <a:latin typeface="Microsoft YaHei"/>
               </a:rPr>
-              <a:t>2026-08-28</a:t>
+              <a:t>2026-08-31</a:t>
             </a:r>
           </a:p>
         </p:txBody>
@@ -7169,7 +7169,7 @@
                 </a:solidFill>
                 <a:latin typeface="Microsoft YaHei"/>
               </a:rPr>
-              <a:t>1.2566</a:t>
+              <a:t>1.2531</a:t>
             </a:r>
           </a:p>
         </p:txBody>
@@ -7203,7 +7203,7 @@
                 </a:solidFill>
                 <a:latin typeface="Microsoft YaHei"/>
               </a:rPr>
-              <a:t>2026-08-27</a:t>
+              <a:t>2026-08-28</a:t>
             </a:r>
           </a:p>
         </p:txBody>
@@ -7305,7 +7305,7 @@
                 </a:solidFill>
                 <a:latin typeface="Microsoft YaHei"/>
               </a:rPr>
-              <a:t>2.0186</a:t>
+              <a:t>2.0225</a:t>
             </a:r>
           </a:p>
         </p:txBody>
@@ -7339,7 +7339,7 @@
                 </a:solidFill>
                 <a:latin typeface="Microsoft YaHei"/>
               </a:rPr>
-              <a:t>2026-08-28</a:t>
+              <a:t>2026-08-31</a:t>
             </a:r>
           </a:p>
         </p:txBody>
@@ -7737,7 +7737,7 @@
         <p:spPr>
           <a:xfrm>
             <a:off x="8549640" y="1737360"/>
-            <a:ext cx="1214878" cy="201168"/>
+            <a:ext cx="1225990" cy="201168"/>
           </a:xfrm>
           <a:prstGeom prst="rect">
             <a:avLst/>
@@ -7959,7 +7959,7 @@
         <p:spPr>
           <a:xfrm>
             <a:off x="8549640" y="2331720"/>
-            <a:ext cx="769470" cy="201168"/>
+            <a:ext cx="773896" cy="201168"/>
           </a:xfrm>
           <a:prstGeom prst="rect">
             <a:avLst/>
@@ -8022,7 +8022,7 @@
                 </a:solidFill>
                 <a:latin typeface="Microsoft YaHei"/>
               </a:rPr>
-              <a:t>13.00%</a:t>
+              <a:t>12.96%</a:t>
             </a:r>
           </a:p>
         </p:txBody>
@@ -8181,7 +8181,7 @@
         <p:spPr>
           <a:xfrm>
             <a:off x="8549640" y="2926080"/>
-            <a:ext cx="1325606" cy="201168"/>
+            <a:ext cx="1327604" cy="201168"/>
           </a:xfrm>
           <a:prstGeom prst="rect">
             <a:avLst/>
@@ -8244,7 +8244,7 @@
                 </a:solidFill>
                 <a:latin typeface="Microsoft YaHei"/>
               </a:rPr>
-              <a:t>22.39%</a:t>
+              <a:t>22.22%</a:t>
             </a:r>
           </a:p>
         </p:txBody>
@@ -8403,7 +8403,7 @@
         <p:spPr>
           <a:xfrm>
             <a:off x="8549640" y="3520440"/>
-            <a:ext cx="928300" cy="201168"/>
+            <a:ext cx="937130" cy="201168"/>
           </a:xfrm>
           <a:prstGeom prst="rect">
             <a:avLst/>
@@ -8466,7 +8466,7 @@
                 </a:solidFill>
                 <a:latin typeface="Microsoft YaHei"/>
               </a:rPr>
-              <a:t>15.68%</a:t>
+              <a:t>15.69%</a:t>
             </a:r>
           </a:p>
         </p:txBody>
@@ -8688,7 +8688,7 @@
                 </a:solidFill>
                 <a:latin typeface="Microsoft YaHei"/>
               </a:rPr>
-              <a:t>40.16%</a:t>
+              <a:t>39.80%</a:t>
             </a:r>
           </a:p>
         </p:txBody>
@@ -9108,7 +9108,7 @@
                 </a:solidFill>
                 <a:latin typeface="Microsoft YaHei"/>
               </a:rPr>
-              <a:t>2026-08-31</a:t>
+              <a:t>2026-09-01</a:t>
             </a:r>
           </a:p>
         </p:txBody>
@@ -9244,7 +9244,7 @@
                 </a:solidFill>
                 <a:latin typeface="Microsoft YaHei"/>
               </a:rPr>
-              <a:t>2026-08-28</a:t>
+              <a:t>2026-08-31</a:t>
             </a:r>
           </a:p>
         </p:txBody>
@@ -9380,7 +9380,7 @@
                 </a:solidFill>
                 <a:latin typeface="Microsoft YaHei"/>
               </a:rPr>
-              <a:t>2026-08-28</a:t>
+              <a:t>2026-08-31</a:t>
             </a:r>
           </a:p>
         </p:txBody>
@@ -9516,7 +9516,7 @@
                 </a:solidFill>
                 <a:latin typeface="Microsoft YaHei"/>
               </a:rPr>
-              <a:t>2026-08-27</a:t>
+              <a:t>2026-08-28</a:t>
             </a:r>
           </a:p>
         </p:txBody>
@@ -9652,7 +9652,7 @@
                 </a:solidFill>
                 <a:latin typeface="Microsoft YaHei"/>
               </a:rPr>
-              <a:t>2026-08-28</a:t>
+              <a:t>2026-08-31</a:t>
             </a:r>
           </a:p>
         </p:txBody>

</xml_diff>